<commit_message>
publish notes on real numbers
</commit_message>
<xml_diff>
--- a/Thumbnail.pptx
+++ b/Thumbnail.pptx
@@ -264,7 +264,7 @@
           <a:p>
             <a:fld id="{78891461-C6EA-4276-8BAF-69066A4B608C}" type="datetimeFigureOut">
               <a:rPr lang="en-AU" smtClean="0"/>
-              <a:t>22/02/2026</a:t>
+              <a:t>14/04/2026</a:t>
             </a:fld>
             <a:endParaRPr lang="en-AU"/>
           </a:p>
@@ -464,7 +464,7 @@
           <a:p>
             <a:fld id="{78891461-C6EA-4276-8BAF-69066A4B608C}" type="datetimeFigureOut">
               <a:rPr lang="en-AU" smtClean="0"/>
-              <a:t>22/02/2026</a:t>
+              <a:t>14/04/2026</a:t>
             </a:fld>
             <a:endParaRPr lang="en-AU"/>
           </a:p>
@@ -674,7 +674,7 @@
           <a:p>
             <a:fld id="{78891461-C6EA-4276-8BAF-69066A4B608C}" type="datetimeFigureOut">
               <a:rPr lang="en-AU" smtClean="0"/>
-              <a:t>22/02/2026</a:t>
+              <a:t>14/04/2026</a:t>
             </a:fld>
             <a:endParaRPr lang="en-AU"/>
           </a:p>
@@ -874,7 +874,7 @@
           <a:p>
             <a:fld id="{78891461-C6EA-4276-8BAF-69066A4B608C}" type="datetimeFigureOut">
               <a:rPr lang="en-AU" smtClean="0"/>
-              <a:t>22/02/2026</a:t>
+              <a:t>14/04/2026</a:t>
             </a:fld>
             <a:endParaRPr lang="en-AU"/>
           </a:p>
@@ -1150,7 +1150,7 @@
           <a:p>
             <a:fld id="{78891461-C6EA-4276-8BAF-69066A4B608C}" type="datetimeFigureOut">
               <a:rPr lang="en-AU" smtClean="0"/>
-              <a:t>22/02/2026</a:t>
+              <a:t>14/04/2026</a:t>
             </a:fld>
             <a:endParaRPr lang="en-AU"/>
           </a:p>
@@ -1418,7 +1418,7 @@
           <a:p>
             <a:fld id="{78891461-C6EA-4276-8BAF-69066A4B608C}" type="datetimeFigureOut">
               <a:rPr lang="en-AU" smtClean="0"/>
-              <a:t>22/02/2026</a:t>
+              <a:t>14/04/2026</a:t>
             </a:fld>
             <a:endParaRPr lang="en-AU"/>
           </a:p>
@@ -1833,7 +1833,7 @@
           <a:p>
             <a:fld id="{78891461-C6EA-4276-8BAF-69066A4B608C}" type="datetimeFigureOut">
               <a:rPr lang="en-AU" smtClean="0"/>
-              <a:t>22/02/2026</a:t>
+              <a:t>14/04/2026</a:t>
             </a:fld>
             <a:endParaRPr lang="en-AU"/>
           </a:p>
@@ -1975,7 +1975,7 @@
           <a:p>
             <a:fld id="{78891461-C6EA-4276-8BAF-69066A4B608C}" type="datetimeFigureOut">
               <a:rPr lang="en-AU" smtClean="0"/>
-              <a:t>22/02/2026</a:t>
+              <a:t>14/04/2026</a:t>
             </a:fld>
             <a:endParaRPr lang="en-AU"/>
           </a:p>
@@ -2088,7 +2088,7 @@
           <a:p>
             <a:fld id="{78891461-C6EA-4276-8BAF-69066A4B608C}" type="datetimeFigureOut">
               <a:rPr lang="en-AU" smtClean="0"/>
-              <a:t>22/02/2026</a:t>
+              <a:t>14/04/2026</a:t>
             </a:fld>
             <a:endParaRPr lang="en-AU"/>
           </a:p>
@@ -2401,7 +2401,7 @@
           <a:p>
             <a:fld id="{78891461-C6EA-4276-8BAF-69066A4B608C}" type="datetimeFigureOut">
               <a:rPr lang="en-AU" smtClean="0"/>
-              <a:t>22/02/2026</a:t>
+              <a:t>14/04/2026</a:t>
             </a:fld>
             <a:endParaRPr lang="en-AU"/>
           </a:p>
@@ -2690,7 +2690,7 @@
           <a:p>
             <a:fld id="{78891461-C6EA-4276-8BAF-69066A4B608C}" type="datetimeFigureOut">
               <a:rPr lang="en-AU" smtClean="0"/>
-              <a:t>22/02/2026</a:t>
+              <a:t>14/04/2026</a:t>
             </a:fld>
             <a:endParaRPr lang="en-AU"/>
           </a:p>
@@ -2933,7 +2933,7 @@
           <a:p>
             <a:fld id="{78891461-C6EA-4276-8BAF-69066A4B608C}" type="datetimeFigureOut">
               <a:rPr lang="en-AU" smtClean="0"/>
-              <a:t>22/02/2026</a:t>
+              <a:t>14/04/2026</a:t>
             </a:fld>
             <a:endParaRPr lang="en-AU"/>
           </a:p>
@@ -5339,7 +5339,7 @@
         </p:nvGrpSpPr>
         <p:grpSpPr>
           <a:xfrm>
-            <a:off x="6932334" y="3662511"/>
+            <a:off x="6947119" y="4423275"/>
             <a:ext cx="3953692" cy="2299061"/>
             <a:chOff x="775061" y="2917371"/>
             <a:chExt cx="3953692" cy="2299061"/>
@@ -5390,7 +5390,7 @@
             <a:lstStyle/>
             <a:p>
               <a:pPr algn="ctr"/>
-              <a:endParaRPr lang="en-AU"/>
+              <a:endParaRPr lang="en-AU" dirty="0"/>
             </a:p>
           </p:txBody>
         </p:sp>
@@ -5667,7 +5667,7 @@
         </p:nvGrpSpPr>
         <p:grpSpPr>
           <a:xfrm>
-            <a:off x="1305974" y="3865693"/>
+            <a:off x="199603" y="5147638"/>
             <a:ext cx="5094826" cy="1516203"/>
             <a:chOff x="1305974" y="3865693"/>
             <a:chExt cx="5094826" cy="1516203"/>
@@ -5955,6 +5955,469 @@
                   <a:latin typeface="Arial Black" panose="020B0A04020102020204" pitchFamily="34" charset="0"/>
                 </a:rPr>
                 <a:t>NETWORK ENGINEERS</a:t>
+              </a:r>
+            </a:p>
+          </p:txBody>
+        </p:sp>
+      </p:grpSp>
+      <p:grpSp>
+        <p:nvGrpSpPr>
+          <p:cNvPr id="42" name="Group 41">
+            <a:extLst>
+              <a:ext uri="{FF2B5EF4-FFF2-40B4-BE49-F238E27FC236}">
+                <a16:creationId xmlns:a16="http://schemas.microsoft.com/office/drawing/2014/main" id="{2436193E-C861-E229-0BDF-B5ECD19AB790}"/>
+              </a:ext>
+            </a:extLst>
+          </p:cNvPr>
+          <p:cNvGrpSpPr/>
+          <p:nvPr/>
+        </p:nvGrpSpPr>
+        <p:grpSpPr>
+          <a:xfrm>
+            <a:off x="1290479" y="2024130"/>
+            <a:ext cx="3953692" cy="2299061"/>
+            <a:chOff x="1290479" y="2024130"/>
+            <a:chExt cx="3953692" cy="2299061"/>
+          </a:xfrm>
+        </p:grpSpPr>
+        <p:sp>
+          <p:nvSpPr>
+            <p:cNvPr id="38" name="Rectangle 37">
+              <a:extLst>
+                <a:ext uri="{FF2B5EF4-FFF2-40B4-BE49-F238E27FC236}">
+                  <a16:creationId xmlns:a16="http://schemas.microsoft.com/office/drawing/2014/main" id="{6594E23F-D96C-617D-0B65-8816C64BD31E}"/>
+                </a:ext>
+              </a:extLst>
+            </p:cNvPr>
+            <p:cNvSpPr/>
+            <p:nvPr/>
+          </p:nvSpPr>
+          <p:spPr>
+            <a:xfrm>
+              <a:off x="1290479" y="2024130"/>
+              <a:ext cx="3953692" cy="2299061"/>
+            </a:xfrm>
+            <a:prstGeom prst="rect">
+              <a:avLst/>
+            </a:prstGeom>
+            <a:ln>
+              <a:noFill/>
+            </a:ln>
+          </p:spPr>
+          <p:style>
+            <a:lnRef idx="2">
+              <a:schemeClr val="accent1">
+                <a:shade val="15000"/>
+              </a:schemeClr>
+            </a:lnRef>
+            <a:fillRef idx="1">
+              <a:schemeClr val="accent1"/>
+            </a:fillRef>
+            <a:effectRef idx="0">
+              <a:schemeClr val="accent1"/>
+            </a:effectRef>
+            <a:fontRef idx="minor">
+              <a:schemeClr val="lt1"/>
+            </a:fontRef>
+          </p:style>
+          <p:txBody>
+            <a:bodyPr rtlCol="0" anchor="ctr"/>
+            <a:lstStyle/>
+            <a:p>
+              <a:pPr algn="ctr"/>
+              <a:endParaRPr lang="en-AU" dirty="0"/>
+            </a:p>
+          </p:txBody>
+        </p:sp>
+        <p:sp>
+          <p:nvSpPr>
+            <p:cNvPr id="14" name="Rectangle 13">
+              <a:extLst>
+                <a:ext uri="{FF2B5EF4-FFF2-40B4-BE49-F238E27FC236}">
+                  <a16:creationId xmlns:a16="http://schemas.microsoft.com/office/drawing/2014/main" id="{D25F543B-36D7-DF4B-BA3C-BE9AE9D5031A}"/>
+                </a:ext>
+              </a:extLst>
+            </p:cNvPr>
+            <p:cNvSpPr/>
+            <p:nvPr/>
+          </p:nvSpPr>
+          <p:spPr>
+            <a:xfrm>
+              <a:off x="1371397" y="2514856"/>
+              <a:ext cx="3828823" cy="646331"/>
+            </a:xfrm>
+            <a:prstGeom prst="rect">
+              <a:avLst/>
+            </a:prstGeom>
+            <a:noFill/>
+            <a:ln>
+              <a:noFill/>
+            </a:ln>
+            <a:effectLst>
+              <a:outerShdw blurRad="50800" dist="38100" dir="2700000" algn="tl" rotWithShape="0">
+                <a:prstClr val="black">
+                  <a:alpha val="40000"/>
+                </a:prstClr>
+              </a:outerShdw>
+            </a:effectLst>
+          </p:spPr>
+          <p:style>
+            <a:lnRef idx="2">
+              <a:schemeClr val="dk1"/>
+            </a:lnRef>
+            <a:fillRef idx="1">
+              <a:schemeClr val="lt1"/>
+            </a:fillRef>
+            <a:effectRef idx="0">
+              <a:schemeClr val="dk1"/>
+            </a:effectRef>
+            <a:fontRef idx="minor">
+              <a:schemeClr val="dk1"/>
+            </a:fontRef>
+          </p:style>
+          <p:txBody>
+            <a:bodyPr wrap="square" lIns="91440" tIns="45720" rIns="91440" bIns="45720">
+              <a:spAutoFit/>
+            </a:bodyPr>
+            <a:lstStyle/>
+            <a:p>
+              <a:pPr algn="ctr"/>
+              <a:r>
+                <a:rPr lang="en-US" sz="3600" dirty="0">
+                  <a:ln w="0"/>
+                  <a:solidFill>
+                    <a:schemeClr val="bg1">
+                      <a:lumMod val="85000"/>
+                    </a:schemeClr>
+                  </a:solidFill>
+                  <a:effectLst>
+                    <a:outerShdw blurRad="38100" dist="19050" dir="2700000" algn="tl" rotWithShape="0">
+                      <a:schemeClr val="dk1">
+                        <a:alpha val="40000"/>
+                      </a:schemeClr>
+                    </a:outerShdw>
+                  </a:effectLst>
+                  <a:latin typeface="Arial Black" panose="020B0A04020102020204" pitchFamily="34" charset="0"/>
+                </a:rPr>
+                <a:t>Mathematics</a:t>
+              </a:r>
+            </a:p>
+          </p:txBody>
+        </p:sp>
+        <p:sp>
+          <p:nvSpPr>
+            <p:cNvPr id="16" name="Rectangle 15">
+              <a:extLst>
+                <a:ext uri="{FF2B5EF4-FFF2-40B4-BE49-F238E27FC236}">
+                  <a16:creationId xmlns:a16="http://schemas.microsoft.com/office/drawing/2014/main" id="{9D045535-4447-69D7-4C7C-262D840F5277}"/>
+                </a:ext>
+              </a:extLst>
+            </p:cNvPr>
+            <p:cNvSpPr/>
+            <p:nvPr/>
+          </p:nvSpPr>
+          <p:spPr>
+            <a:xfrm>
+              <a:off x="1560040" y="3240898"/>
+              <a:ext cx="3326673" cy="523220"/>
+            </a:xfrm>
+            <a:prstGeom prst="rect">
+              <a:avLst/>
+            </a:prstGeom>
+            <a:noFill/>
+            <a:ln>
+              <a:noFill/>
+            </a:ln>
+            <a:effectLst>
+              <a:outerShdw blurRad="50800" dist="38100" dir="2700000" algn="tl" rotWithShape="0">
+                <a:prstClr val="black">
+                  <a:alpha val="40000"/>
+                </a:prstClr>
+              </a:outerShdw>
+            </a:effectLst>
+          </p:spPr>
+          <p:style>
+            <a:lnRef idx="2">
+              <a:schemeClr val="dk1"/>
+            </a:lnRef>
+            <a:fillRef idx="1">
+              <a:schemeClr val="lt1"/>
+            </a:fillRef>
+            <a:effectRef idx="0">
+              <a:schemeClr val="dk1"/>
+            </a:effectRef>
+            <a:fontRef idx="minor">
+              <a:schemeClr val="dk1"/>
+            </a:fontRef>
+          </p:style>
+          <p:txBody>
+            <a:bodyPr wrap="square" lIns="91440" tIns="45720" rIns="91440" bIns="45720">
+              <a:spAutoFit/>
+            </a:bodyPr>
+            <a:lstStyle/>
+            <a:p>
+              <a:endParaRPr lang="en-US" sz="2800" dirty="0">
+                <a:ln w="0"/>
+                <a:solidFill>
+                  <a:schemeClr val="bg1">
+                    <a:lumMod val="85000"/>
+                  </a:schemeClr>
+                </a:solidFill>
+                <a:effectLst>
+                  <a:outerShdw blurRad="38100" dist="19050" dir="2700000" algn="tl" rotWithShape="0">
+                    <a:schemeClr val="dk1">
+                      <a:alpha val="40000"/>
+                    </a:schemeClr>
+                  </a:outerShdw>
+                </a:effectLst>
+                <a:latin typeface="Arial Black" panose="020B0A04020102020204" pitchFamily="34" charset="0"/>
+              </a:endParaRPr>
+            </a:p>
+          </p:txBody>
+        </p:sp>
+        <p:sp>
+          <p:nvSpPr>
+            <p:cNvPr id="29" name="Rectangle 28">
+              <a:extLst>
+                <a:ext uri="{FF2B5EF4-FFF2-40B4-BE49-F238E27FC236}">
+                  <a16:creationId xmlns:a16="http://schemas.microsoft.com/office/drawing/2014/main" id="{F9F7BE7A-B0EE-A892-81CC-DEDA42F87C1D}"/>
+                </a:ext>
+              </a:extLst>
+            </p:cNvPr>
+            <p:cNvSpPr/>
+            <p:nvPr/>
+          </p:nvSpPr>
+          <p:spPr>
+            <a:xfrm>
+              <a:off x="1447497" y="3430461"/>
+              <a:ext cx="3616061" cy="430887"/>
+            </a:xfrm>
+            <a:prstGeom prst="rect">
+              <a:avLst/>
+            </a:prstGeom>
+            <a:noFill/>
+          </p:spPr>
+          <p:txBody>
+            <a:bodyPr wrap="square" lIns="91440" tIns="45720" rIns="91440" bIns="45720">
+              <a:spAutoFit/>
+            </a:bodyPr>
+            <a:lstStyle/>
+            <a:p>
+              <a:pPr algn="ctr"/>
+              <a:r>
+                <a:rPr lang="en-US" sz="2200" cap="none" spc="0" dirty="0">
+                  <a:ln w="0"/>
+                  <a:solidFill>
+                    <a:schemeClr val="bg1">
+                      <a:lumMod val="85000"/>
+                    </a:schemeClr>
+                  </a:solidFill>
+                  <a:effectLst>
+                    <a:outerShdw blurRad="38100" dist="19050" dir="2700000" algn="tl" rotWithShape="0">
+                      <a:schemeClr val="dk1">
+                        <a:alpha val="40000"/>
+                      </a:schemeClr>
+                    </a:outerShdw>
+                  </a:effectLst>
+                  <a:latin typeface="Arial Black" panose="020B0A04020102020204" pitchFamily="34" charset="0"/>
+                </a:rPr>
+                <a:t>Relearning Math</a:t>
+              </a:r>
+            </a:p>
+          </p:txBody>
+        </p:sp>
+      </p:grpSp>
+      <p:grpSp>
+        <p:nvGrpSpPr>
+          <p:cNvPr id="48" name="Group 47">
+            <a:extLst>
+              <a:ext uri="{FF2B5EF4-FFF2-40B4-BE49-F238E27FC236}">
+                <a16:creationId xmlns:a16="http://schemas.microsoft.com/office/drawing/2014/main" id="{3D79D1F0-0473-99A1-8E9F-12F82C33F570}"/>
+              </a:ext>
+            </a:extLst>
+          </p:cNvPr>
+          <p:cNvGrpSpPr/>
+          <p:nvPr/>
+        </p:nvGrpSpPr>
+        <p:grpSpPr>
+          <a:xfrm>
+            <a:off x="6275939" y="425171"/>
+            <a:ext cx="5094826" cy="1516203"/>
+            <a:chOff x="6275939" y="425171"/>
+            <a:chExt cx="5094826" cy="1516203"/>
+          </a:xfrm>
+        </p:grpSpPr>
+        <p:sp>
+          <p:nvSpPr>
+            <p:cNvPr id="44" name="Rectangle 43">
+              <a:extLst>
+                <a:ext uri="{FF2B5EF4-FFF2-40B4-BE49-F238E27FC236}">
+                  <a16:creationId xmlns:a16="http://schemas.microsoft.com/office/drawing/2014/main" id="{FA8F4541-2518-B6D2-1F19-44C5D18AB466}"/>
+                </a:ext>
+              </a:extLst>
+            </p:cNvPr>
+            <p:cNvSpPr/>
+            <p:nvPr/>
+          </p:nvSpPr>
+          <p:spPr>
+            <a:xfrm>
+              <a:off x="6275939" y="425171"/>
+              <a:ext cx="5094826" cy="1516203"/>
+            </a:xfrm>
+            <a:prstGeom prst="rect">
+              <a:avLst/>
+            </a:prstGeom>
+            <a:ln>
+              <a:noFill/>
+            </a:ln>
+          </p:spPr>
+          <p:style>
+            <a:lnRef idx="2">
+              <a:schemeClr val="accent1">
+                <a:shade val="15000"/>
+              </a:schemeClr>
+            </a:lnRef>
+            <a:fillRef idx="1">
+              <a:schemeClr val="accent1"/>
+            </a:fillRef>
+            <a:effectRef idx="0">
+              <a:schemeClr val="accent1"/>
+            </a:effectRef>
+            <a:fontRef idx="minor">
+              <a:schemeClr val="lt1"/>
+            </a:fontRef>
+          </p:style>
+          <p:txBody>
+            <a:bodyPr rtlCol="0" anchor="ctr"/>
+            <a:lstStyle/>
+            <a:p>
+              <a:pPr algn="ctr"/>
+              <a:endParaRPr lang="en-AU"/>
+            </a:p>
+          </p:txBody>
+        </p:sp>
+        <p:sp>
+          <p:nvSpPr>
+            <p:cNvPr id="26" name="Rectangle 25">
+              <a:extLst>
+                <a:ext uri="{FF2B5EF4-FFF2-40B4-BE49-F238E27FC236}">
+                  <a16:creationId xmlns:a16="http://schemas.microsoft.com/office/drawing/2014/main" id="{D9ED368B-B117-993B-C9BD-1685F1F6602C}"/>
+                </a:ext>
+              </a:extLst>
+            </p:cNvPr>
+            <p:cNvSpPr/>
+            <p:nvPr/>
+          </p:nvSpPr>
+          <p:spPr>
+            <a:xfrm>
+              <a:off x="6947119" y="557869"/>
+              <a:ext cx="3836902" cy="707886"/>
+            </a:xfrm>
+            <a:prstGeom prst="rect">
+              <a:avLst/>
+            </a:prstGeom>
+            <a:noFill/>
+            <a:ln>
+              <a:noFill/>
+            </a:ln>
+            <a:effectLst>
+              <a:outerShdw blurRad="50800" dist="38100" dir="2700000" algn="tl" rotWithShape="0">
+                <a:prstClr val="black">
+                  <a:alpha val="40000"/>
+                </a:prstClr>
+              </a:outerShdw>
+            </a:effectLst>
+          </p:spPr>
+          <p:style>
+            <a:lnRef idx="2">
+              <a:schemeClr val="dk1"/>
+            </a:lnRef>
+            <a:fillRef idx="1">
+              <a:schemeClr val="lt1"/>
+            </a:fillRef>
+            <a:effectRef idx="0">
+              <a:schemeClr val="dk1"/>
+            </a:effectRef>
+            <a:fontRef idx="minor">
+              <a:schemeClr val="dk1"/>
+            </a:fontRef>
+          </p:style>
+          <p:txBody>
+            <a:bodyPr wrap="square" lIns="91440" tIns="45720" rIns="91440" bIns="45720">
+              <a:spAutoFit/>
+            </a:bodyPr>
+            <a:lstStyle/>
+            <a:p>
+              <a:pPr algn="ctr"/>
+              <a:r>
+                <a:rPr lang="en-US" sz="4000" dirty="0">
+                  <a:ln w="0"/>
+                  <a:solidFill>
+                    <a:schemeClr val="bg1">
+                      <a:lumMod val="75000"/>
+                    </a:schemeClr>
+                  </a:solidFill>
+                  <a:effectLst>
+                    <a:outerShdw blurRad="38100" dist="19050" dir="2700000" algn="tl" rotWithShape="0">
+                      <a:schemeClr val="dk1">
+                        <a:alpha val="40000"/>
+                      </a:schemeClr>
+                    </a:outerShdw>
+                  </a:effectLst>
+                  <a:latin typeface="Arial Black" panose="020B0A04020102020204" pitchFamily="34" charset="0"/>
+                </a:rPr>
+                <a:t>Mathematics</a:t>
+              </a:r>
+            </a:p>
+          </p:txBody>
+        </p:sp>
+        <p:sp>
+          <p:nvSpPr>
+            <p:cNvPr id="32" name="Rectangle 31">
+              <a:extLst>
+                <a:ext uri="{FF2B5EF4-FFF2-40B4-BE49-F238E27FC236}">
+                  <a16:creationId xmlns:a16="http://schemas.microsoft.com/office/drawing/2014/main" id="{BB5F7EE2-B93B-9F8B-D6A6-78C020226854}"/>
+                </a:ext>
+              </a:extLst>
+            </p:cNvPr>
+            <p:cNvSpPr/>
+            <p:nvPr/>
+          </p:nvSpPr>
+          <p:spPr>
+            <a:xfrm>
+              <a:off x="7311220" y="1373009"/>
+              <a:ext cx="3221990" cy="430887"/>
+            </a:xfrm>
+            <a:prstGeom prst="rect">
+              <a:avLst/>
+            </a:prstGeom>
+            <a:noFill/>
+          </p:spPr>
+          <p:txBody>
+            <a:bodyPr wrap="square" lIns="91440" tIns="45720" rIns="91440" bIns="45720">
+              <a:spAutoFit/>
+            </a:bodyPr>
+            <a:lstStyle/>
+            <a:p>
+              <a:pPr algn="ctr"/>
+              <a:r>
+                <a:rPr lang="en-US" sz="2200" cap="none" spc="0" dirty="0">
+                  <a:ln w="0"/>
+                  <a:solidFill>
+                    <a:schemeClr val="bg1">
+                      <a:lumMod val="75000"/>
+                    </a:schemeClr>
+                  </a:solidFill>
+                  <a:effectLst>
+                    <a:outerShdw blurRad="38100" dist="19050" dir="2700000" algn="tl" rotWithShape="0">
+                      <a:schemeClr val="dk1">
+                        <a:alpha val="40000"/>
+                      </a:schemeClr>
+                    </a:outerShdw>
+                  </a:effectLst>
+                  <a:latin typeface="Arial Black" panose="020B0A04020102020204" pitchFamily="34" charset="0"/>
+                </a:rPr>
+                <a:t>Relearning Math</a:t>
               </a:r>
             </a:p>
           </p:txBody>

</xml_diff>